<commit_message>
round2: deck v3 — R12 example: GiantWeave is on time but a day late if reworked
Co-Authored-By: Claude Fable 5.1 <noreply@anthropic.com>
</commit_message>
<xml_diff>
--- a/round2/06_汇报更新/Presentation_GroupNN_Sprint1_DRAFT_v3.pptx
+++ b/round2/06_汇报更新/Presentation_GroupNN_Sprint1_DRAFT_v3.pptx
@@ -934,7 +934,7 @@
           <a:lstStyle/>
           <a:p>
             <a:r>
-              <a:t>[50 s] The language model only reads: order, pieces, date, constraint. Then code takes over, with three mechanisms. One, the text decides: every extracted value is checked against the message, and anything the message does not contain is dropped. Two, eligibility before ranking: three hard checks, then two dates per eligible shop, expected and if reworked, and only then a ranking by the objective. Three, traced, then booked: every number in the explanation comes from a tool output, and nothing is booked until the dispatcher confirms. The bottom row is one real message going through: the standing constraint recorded, four shops eligible, GiantWeave on time even if reworked.</a:t>
+              <a:t>[50 s] The language model only reads: order, pieces, date, constraint. Then code takes over, with three mechanisms. One, the text decides: every extracted value is checked against the message, and anything the message does not contain is dropped. Two, eligibility before ranking: three hard checks, then two dates per eligible shop, expected and if reworked, and only then a ranking by the objective. Three, traced, then booked: every number in the explanation comes from a tool output, and nothing is booked until the dispatcher confirms. The bottom row is one real message going through: the standing constraint recorded, four shops eligible, GiantWeave on time, a day late if reworked; the dispatcher sees both dates.</a:t>
             </a:r>
           </a:p>
         </p:txBody>
@@ -10545,7 +10545,7 @@
                 </a:solidFill>
                 <a:latin typeface="Calibri"/>
               </a:rPr>
-              <a:t>4 shops eligible. GiantWeave back Fri 10 Apr; Sat 11 Apr if reworked, still on time</a:t>
+              <a:t>4 shops eligible. GiantWeave back Fri 10 Apr, on time; Sat 11 Apr if reworked, a day late</a:t>
             </a:r>
           </a:p>
         </p:txBody>

</xml_diff>